<commit_message>
Add Arctic Embed model comparison
</commit_message>
<xml_diff>
--- a/presentation/emotional_directions_class_presentation.pptx
+++ b/presentation/emotional_directions_class_presentation.pptx
@@ -4659,7 +4659,7 @@
                   <a:srgbClr val="16201C"/>
                 </a:solidFill>
               </a:rPr>
-              <a:t>Bielik hidden states</a:t>
+              <a:t>Arctic Embed L v2</a:t>
             </a:r>
             <a:endParaRPr lang="en-US" sz="1150" dirty="0"/>
           </a:p>
@@ -4695,6 +4695,42 @@
                   <a:srgbClr val="16201C"/>
                 </a:solidFill>
               </a:rPr>
+              <a:t>Bielik hidden states</a:t>
+            </a:r>
+            <a:endParaRPr lang="en-US" sz="1150" dirty="0"/>
+          </a:p>
+        </p:txBody>
+      </p:sp>
+      <p:sp>
+        <p:nvSpPr>
+          <p:cNvPr id="10" name="Text 8"/>
+          <p:cNvSpPr/>
+          <p:nvPr/>
+        </p:nvSpPr>
+        <p:spPr>
+          <a:xfrm>
+            <a:off x="685800" y="3813048"/>
+            <a:ext cx="2286000" cy="201168"/>
+          </a:xfrm>
+          <a:prstGeom prst="rect">
+            <a:avLst/>
+          </a:prstGeom>
+          <a:noFill/>
+          <a:ln/>
+        </p:spPr>
+        <p:txBody>
+          <a:bodyPr wrap="square" lIns="0" tIns="0" rIns="0" bIns="0" rtlCol="0" anchor="ctr"/>
+          <a:lstStyle/>
+          <a:p>
+            <a:pPr indent="0" marL="0">
+              <a:buNone/>
+            </a:pPr>
+            <a:r>
+              <a:rPr lang="en-US" sz="1150" dirty="0">
+                <a:solidFill>
+                  <a:srgbClr val="16201C"/>
+                </a:solidFill>
+              </a:rPr>
               <a:t>MMLW-RoBERTa</a:t>
             </a:r>
             <a:endParaRPr lang="en-US" sz="1150" dirty="0"/>
@@ -4703,7 +4739,7 @@
       </p:sp>
       <p:sp>
         <p:nvSpPr>
-          <p:cNvPr id="10" name="Text 8"/>
+          <p:cNvPr id="11" name="Text 9"/>
           <p:cNvSpPr/>
           <p:nvPr/>
         </p:nvSpPr>
@@ -4739,7 +4775,7 @@
       </p:sp>
       <p:sp>
         <p:nvSpPr>
-          <p:cNvPr id="11" name="Text 9"/>
+          <p:cNvPr id="12" name="Text 10"/>
           <p:cNvSpPr/>
           <p:nvPr/>
         </p:nvSpPr>
@@ -4775,7 +4811,7 @@
       </p:sp>
       <p:sp>
         <p:nvSpPr>
-          <p:cNvPr id="12" name="Text 10"/>
+          <p:cNvPr id="13" name="Text 11"/>
           <p:cNvSpPr/>
           <p:nvPr/>
         </p:nvSpPr>
@@ -4811,7 +4847,7 @@
       </p:sp>
       <p:sp>
         <p:nvSpPr>
-          <p:cNvPr id="13" name="Text 11"/>
+          <p:cNvPr id="14" name="Text 12"/>
           <p:cNvSpPr/>
           <p:nvPr/>
         </p:nvSpPr>
@@ -4847,7 +4883,7 @@
       </p:sp>
       <p:sp>
         <p:nvSpPr>
-          <p:cNvPr id="14" name="Text 12"/>
+          <p:cNvPr id="15" name="Text 13"/>
           <p:cNvSpPr/>
           <p:nvPr/>
         </p:nvSpPr>
@@ -4883,7 +4919,7 @@
       </p:sp>
       <p:sp>
         <p:nvSpPr>
-          <p:cNvPr id="15" name="Text 13"/>
+          <p:cNvPr id="16" name="Text 14"/>
           <p:cNvSpPr/>
           <p:nvPr/>
         </p:nvSpPr>
@@ -4919,7 +4955,7 @@
       </p:sp>
       <p:sp>
         <p:nvSpPr>
-          <p:cNvPr id="16" name="Text 14"/>
+          <p:cNvPr id="17" name="Text 15"/>
           <p:cNvSpPr/>
           <p:nvPr/>
         </p:nvSpPr>
@@ -4955,7 +4991,7 @@
       </p:sp>
       <p:sp>
         <p:nvSpPr>
-          <p:cNvPr id="17" name="Text 15"/>
+          <p:cNvPr id="18" name="Text 16"/>
           <p:cNvSpPr/>
           <p:nvPr/>
         </p:nvSpPr>
@@ -4991,7 +5027,7 @@
       </p:sp>
       <p:sp>
         <p:nvSpPr>
-          <p:cNvPr id="18" name="Text 16"/>
+          <p:cNvPr id="19" name="Text 17"/>
           <p:cNvSpPr/>
           <p:nvPr/>
         </p:nvSpPr>
@@ -5027,7 +5063,7 @@
       </p:sp>
       <p:sp>
         <p:nvSpPr>
-          <p:cNvPr id="19" name="Text 17"/>
+          <p:cNvPr id="20" name="Text 18"/>
           <p:cNvSpPr/>
           <p:nvPr/>
         </p:nvSpPr>
@@ -5063,7 +5099,7 @@
       </p:sp>
       <p:sp>
         <p:nvSpPr>
-          <p:cNvPr id="20" name="Text 18"/>
+          <p:cNvPr id="21" name="Text 19"/>
           <p:cNvSpPr/>
           <p:nvPr/>
         </p:nvSpPr>
@@ -5099,7 +5135,7 @@
       </p:sp>
       <p:sp>
         <p:nvSpPr>
-          <p:cNvPr id="21" name="Text 19"/>
+          <p:cNvPr id="22" name="Text 20"/>
           <p:cNvSpPr/>
           <p:nvPr/>
         </p:nvSpPr>
@@ -5135,7 +5171,7 @@
       </p:sp>
       <p:sp>
         <p:nvSpPr>
-          <p:cNvPr id="22" name="Text 20"/>
+          <p:cNvPr id="23" name="Text 21"/>
           <p:cNvSpPr/>
           <p:nvPr/>
         </p:nvSpPr>
@@ -5171,7 +5207,7 @@
       </p:sp>
       <p:sp>
         <p:nvSpPr>
-          <p:cNvPr id="23" name="Text 21"/>
+          <p:cNvPr id="24" name="Text 22"/>
           <p:cNvSpPr/>
           <p:nvPr/>
         </p:nvSpPr>
@@ -5207,7 +5243,7 @@
       </p:sp>
       <p:sp>
         <p:nvSpPr>
-          <p:cNvPr id="24" name="Shape 22"/>
+          <p:cNvPr id="25" name="Shape 23"/>
           <p:cNvSpPr/>
           <p:nvPr/>
         </p:nvSpPr>
@@ -5230,7 +5266,7 @@
       </p:sp>
       <p:sp>
         <p:nvSpPr>
-          <p:cNvPr id="25" name="Text 23"/>
+          <p:cNvPr id="26" name="Text 24"/>
           <p:cNvSpPr/>
           <p:nvPr/>
         </p:nvSpPr>
@@ -5266,7 +5302,7 @@
       </p:sp>
       <p:sp>
         <p:nvSpPr>
-          <p:cNvPr id="26" name="Shape 24"/>
+          <p:cNvPr id="27" name="Shape 25"/>
           <p:cNvSpPr/>
           <p:nvPr/>
         </p:nvSpPr>
@@ -5293,7 +5329,7 @@
       </p:sp>
       <p:sp>
         <p:nvSpPr>
-          <p:cNvPr id="27" name="Text 25"/>
+          <p:cNvPr id="28" name="Text 26"/>
           <p:cNvSpPr/>
           <p:nvPr/>
         </p:nvSpPr>
@@ -5329,7 +5365,7 @@
       </p:sp>
       <p:sp>
         <p:nvSpPr>
-          <p:cNvPr id="28" name="Shape 26"/>
+          <p:cNvPr id="29" name="Shape 27"/>
           <p:cNvSpPr/>
           <p:nvPr/>
         </p:nvSpPr>
@@ -5356,7 +5392,7 @@
       </p:sp>
       <p:sp>
         <p:nvSpPr>
-          <p:cNvPr id="29" name="Text 27"/>
+          <p:cNvPr id="30" name="Text 28"/>
           <p:cNvSpPr/>
           <p:nvPr/>
         </p:nvSpPr>
@@ -5392,7 +5428,7 @@
       </p:sp>
       <p:sp>
         <p:nvSpPr>
-          <p:cNvPr id="30" name="Shape 28"/>
+          <p:cNvPr id="31" name="Shape 29"/>
           <p:cNvSpPr/>
           <p:nvPr/>
         </p:nvSpPr>
@@ -5419,7 +5455,7 @@
       </p:sp>
       <p:sp>
         <p:nvSpPr>
-          <p:cNvPr id="31" name="Text 29"/>
+          <p:cNvPr id="32" name="Text 30"/>
           <p:cNvSpPr/>
           <p:nvPr/>
         </p:nvSpPr>
@@ -5455,7 +5491,7 @@
       </p:sp>
       <p:sp>
         <p:nvSpPr>
-          <p:cNvPr id="32" name="Shape 30"/>
+          <p:cNvPr id="33" name="Shape 31"/>
           <p:cNvSpPr/>
           <p:nvPr/>
         </p:nvSpPr>
@@ -5482,7 +5518,7 @@
       </p:sp>
       <p:sp>
         <p:nvSpPr>
-          <p:cNvPr id="33" name="Text 31"/>
+          <p:cNvPr id="34" name="Text 32"/>
           <p:cNvSpPr/>
           <p:nvPr/>
         </p:nvSpPr>
@@ -5518,7 +5554,7 @@
       </p:sp>
       <p:sp>
         <p:nvSpPr>
-          <p:cNvPr id="34" name="Text 32"/>
+          <p:cNvPr id="35" name="Text 33"/>
           <p:cNvSpPr/>
           <p:nvPr/>
         </p:nvSpPr>
@@ -5554,7 +5590,7 @@
       </p:sp>
       <p:sp>
         <p:nvSpPr>
-          <p:cNvPr id="35" name="Text 33"/>
+          <p:cNvPr id="36" name="Text 34"/>
           <p:cNvSpPr/>
           <p:nvPr/>
         </p:nvSpPr>
@@ -7326,7 +7362,7 @@
                   <a:srgbClr val="5F706A"/>
                 </a:solidFill>
               </a:rPr>
-              <a:t>Gemini and Qwen are the cleanest embedding-model comparison. Bielik is interesting as an exploratory hidden-state condition; MMLW-RoBERTa should not support cross-lingual claims here.</a:t>
+              <a:t>Gemini, Qwen, and Arctic are the cleanest embedding-model comparison. Bielik is interesting as an exploratory hidden-state condition; MMLW-RoBERTa should not support cross-lingual claims here.</a:t>
             </a:r>
             <a:endParaRPr lang="en-US" sz="1350" dirty="0"/>
           </a:p>

</xml_diff>